<commit_message>
Kit 3 ships: seven supporting files, drift fixed, verified stats, drop 65 and pin
Co-Authored-By: Claude Sonnet 5.5 <noreply@anthropic.com>
Claude-Session: https://claude.ai/code/session_01FRkzusVyTtLpghnPcda6Y6
</commit_message>
<xml_diff>
--- a/kits/kit03-tpt/Kit03_PresentationDeck.pptx
+++ b/kits/kit03-tpt/Kit03_PresentationDeck.pptx
@@ -1767,7 +1767,7 @@
           <a:p>
             <a:r>
               <a:rPr lang="en-US" dirty="0"/>
-              <a:t>This is a leave-up reference slide. Point new arrivals or lost participants back to it rather than re-explaining verbally each time.</a:t>
+              <a:t>Say: four moves, on screen the whole time you work. Nobody edits code to enter questions or save the game. This is a leave-up reference slide; point new arrivals or lost participants back to it rather than re-explaining verbally each time.</a:t>
             </a:r>
             <a:endParaRPr lang="en-US" dirty="0"/>
           </a:p>
@@ -1855,7 +1855,7 @@
           <a:p>
             <a:r>
               <a:rPr lang="en-US" dirty="0"/>
-              <a:t>This is the exact block from the starter file, shown large so nobody has to hunt for it. The "idea" field is what lets the game bring a missed question back later; the "why" field is what it shows after a wrong answer. Both matter and both are one line each.</a:t>
+              <a:t>Say: this is the whole setup screen in three ways. Then run the AI prompt live on the projector: type a topic, copy the prompt, paste it into your AI tool, paste the twelve lines back, press Load these questions. Read the result out loud against what a teacher would actually want and point at one real thing it got wrong or made too easy. Fast is not the same as right; that is the lesson. If a line will not load the page names it and says why; that is a teaching gift.</a:t>
             </a:r>
             <a:endParaRPr lang="en-US" dirty="0"/>
           </a:p>
@@ -2295,7 +2295,7 @@
           <a:p>
             <a:r>
               <a:rPr lang="en-US" dirty="0"/>
-              <a:t>This is the failure the whole "save a copy first" habit exists for. If someone did not save a copy, they re-paste their original questions into the current file rather than starting over; either way, stay calm and visible about it, since a live recovery is more reassuring than a clean run.</a:t>
+              <a:t>This is the failure the whole "save a copy first" habit exists for. If someone did not save a copy, they press Put my own questions in and type or paste their questions back in rather than starting over; either way, stay calm and visible about it, since a live recovery is more reassuring than a clean run.</a:t>
             </a:r>
             <a:endParaRPr lang="en-US" dirty="0"/>
           </a:p>
@@ -3922,7 +3922,7 @@
                 <a:ea typeface="Inter" pitchFamily="34" charset="-122"/>
                 <a:cs typeface="Inter" pitchFamily="34" charset="-120"/>
               </a:rPr>
-              <a:t>TRACK A · AI FOUNDATIONS · KIT 3 OF 20</a:t>
+              <a:t>TRACK A · AI FOUNDATIONS · KIT 3</a:t>
             </a:r>
             <a:endParaRPr lang="en-US" sz="1500" dirty="0"/>
           </a:p>
@@ -4933,7 +4933,7 @@
                 <a:ea typeface="Inter" pitchFamily="34" charset="-122"/>
                 <a:cs typeface="Inter" pitchFamily="34" charset="-120"/>
               </a:rPr>
-              <a:t>the file, updated, with her eight questions in the block at the top and her new title in the title bar.</a:t>
+              <a:t>the file, updated, with her eight questions loaded and her new title on the opening screen.</a:t>
             </a:r>
             <a:endParaRPr lang="en-US" sz="1600" dirty="0"/>
           </a:p>
@@ -9960,7 +9960,7 @@
                 <a:ea typeface="Inter" pitchFamily="34" charset="-122"/>
                 <a:cs typeface="Inter" pitchFamily="34" charset="-120"/>
               </a:rPr>
-              <a:t>Maryland’s AI Ready Schools Act (SB 720) is now law: every local school system trains its teachers on AI, with the state’s own goal of finishing by July 1, 2027. Virginia and Ohio passed their own 2026 laws the same year.</a:t>
+              <a:t>Maryland’s AI Ready Schools Act (SB 720) is now law: it sets up statewide AI training for teachers, with the law’s own intent of training educators by July 1, 2027. Virginia and Ohio passed their own 2026 laws the same year.</a:t>
             </a:r>
             <a:endParaRPr lang="en-US" sz="1900" dirty="0"/>
           </a:p>
@@ -10065,7 +10065,7 @@
                 <a:ea typeface="Inter" pitchFamily="34" charset="-122"/>
                 <a:cs typeface="Inter" pitchFamily="34" charset="-120"/>
               </a:rPr>
-              <a:t>That is how many AI-in-education bills moved through state legislatures in the 2026 session alone. This is not one state. It is a direction.</a:t>
+              <a:t>That is how many AI-in-education bills FutureEd was tracking in state legislatures during the 2026 session. This is not one state. It is a direction.</a:t>
             </a:r>
             <a:endParaRPr lang="en-US" sz="1600" dirty="0"/>
           </a:p>
@@ -11139,7 +11139,7 @@
                 <a:ea typeface="Inter" pitchFamily="34" charset="-122"/>
                 <a:cs typeface="Inter" pitchFamily="34" charset="-120"/>
               </a:rPr>
-              <a:t>Start from the starter file. Swap in your questions, then make two real changes by describing them.</a:t>
+              <a:t>Open the starter file, press Put my own questions in, fill in the form, then make two real changes by describing them.</a:t>
             </a:r>
             <a:endParaRPr lang="en-US" sz="1700" dirty="0"/>
           </a:p>
@@ -11740,7 +11740,7 @@
                 <a:ea typeface="Inter" pitchFamily="34" charset="-122"/>
                 <a:cs typeface="Inter" pitchFamily="34" charset="-120"/>
               </a:rPr>
-              <a:t>Her Track 1: open the file, find the block at the top, replace it.</a:t>
+              <a:t>Her Track 1: open the file, press Put my own questions in, fill the form.</a:t>
             </a:r>
             <a:endParaRPr lang="en-US" sz="1000" dirty="0"/>
           </a:p>
@@ -11832,12 +11832,12 @@
         </p:nvSpPr>
         <p:spPr>
           <a:xfrm>
-            <a:off x="640080" y="1508760"/>
-            <a:ext cx="10972800" cy="1234440"/>
+            <a:off x="640080" y="1417320"/>
+            <a:ext cx="10972800" cy="969264"/>
           </a:xfrm>
           <a:prstGeom prst="roundRect">
             <a:avLst>
-              <a:gd name="adj" fmla="val 6667"/>
+              <a:gd name="adj" fmla="val 8491"/>
             </a:avLst>
           </a:prstGeom>
           <a:solidFill>
@@ -11859,8 +11859,8 @@
         </p:nvSpPr>
         <p:spPr>
           <a:xfrm>
-            <a:off x="914400" y="1892808"/>
-            <a:ext cx="502920" cy="502920"/>
+            <a:off x="914400" y="1664208"/>
+            <a:ext cx="475488" cy="475488"/>
           </a:xfrm>
           <a:prstGeom prst="ellipse">
             <a:avLst/>
@@ -11884,8 +11884,8 @@
         </p:nvSpPr>
         <p:spPr>
           <a:xfrm>
-            <a:off x="914400" y="1892808"/>
-            <a:ext cx="502920" cy="502920"/>
+            <a:off x="914400" y="1664208"/>
+            <a:ext cx="475488" cy="475488"/>
           </a:xfrm>
           <a:prstGeom prst="rect">
             <a:avLst/>
@@ -11923,8 +11923,8 @@
         </p:nvSpPr>
         <p:spPr>
           <a:xfrm>
-            <a:off x="1645920" y="1655064"/>
-            <a:ext cx="9692640" cy="457200"/>
+            <a:off x="1645920" y="1508760"/>
+            <a:ext cx="9692640" cy="384048"/>
           </a:xfrm>
           <a:prstGeom prst="rect">
             <a:avLst/>
@@ -11962,8 +11962,8 @@
         </p:nvSpPr>
         <p:spPr>
           <a:xfrm>
-            <a:off x="1645920" y="2130552"/>
-            <a:ext cx="9692640" cy="548640"/>
+            <a:off x="1645920" y="1911096"/>
+            <a:ext cx="9692640" cy="411480"/>
           </a:xfrm>
           <a:prstGeom prst="rect">
             <a:avLst/>
@@ -12001,12 +12001,12 @@
         </p:nvSpPr>
         <p:spPr>
           <a:xfrm>
-            <a:off x="640080" y="2926080"/>
-            <a:ext cx="10972800" cy="1234440"/>
+            <a:off x="640080" y="2496312"/>
+            <a:ext cx="10972800" cy="969264"/>
           </a:xfrm>
           <a:prstGeom prst="roundRect">
             <a:avLst>
-              <a:gd name="adj" fmla="val 6667"/>
+              <a:gd name="adj" fmla="val 8491"/>
             </a:avLst>
           </a:prstGeom>
           <a:solidFill>
@@ -12028,8 +12028,8 @@
         </p:nvSpPr>
         <p:spPr>
           <a:xfrm>
-            <a:off x="914400" y="3310128"/>
-            <a:ext cx="502920" cy="502920"/>
+            <a:off x="914400" y="2743200"/>
+            <a:ext cx="475488" cy="475488"/>
           </a:xfrm>
           <a:prstGeom prst="ellipse">
             <a:avLst/>
@@ -12053,8 +12053,8 @@
         </p:nvSpPr>
         <p:spPr>
           <a:xfrm>
-            <a:off x="914400" y="3310128"/>
-            <a:ext cx="502920" cy="502920"/>
+            <a:off x="914400" y="2743200"/>
+            <a:ext cx="475488" cy="475488"/>
           </a:xfrm>
           <a:prstGeom prst="rect">
             <a:avLst/>
@@ -12092,8 +12092,8 @@
         </p:nvSpPr>
         <p:spPr>
           <a:xfrm>
-            <a:off x="1645920" y="3072384"/>
-            <a:ext cx="9692640" cy="457200"/>
+            <a:off x="1645920" y="2587752"/>
+            <a:ext cx="9692640" cy="384048"/>
           </a:xfrm>
           <a:prstGeom prst="rect">
             <a:avLst/>
@@ -12117,7 +12117,7 @@
                 <a:ea typeface="Inter" pitchFamily="34" charset="-122"/>
                 <a:cs typeface="Inter" pitchFamily="34" charset="-120"/>
               </a:rPr>
-              <a:t>Replace the question block</a:t>
+              <a:t>Press “Put my own questions in”</a:t>
             </a:r>
             <a:endParaRPr lang="en-US" sz="1900" dirty="0"/>
           </a:p>
@@ -12131,8 +12131,8 @@
         </p:nvSpPr>
         <p:spPr>
           <a:xfrm>
-            <a:off x="1645920" y="3547872"/>
-            <a:ext cx="9692640" cy="548640"/>
+            <a:off x="1645920" y="2990088"/>
+            <a:ext cx="9692640" cy="411480"/>
           </a:xfrm>
           <a:prstGeom prst="rect">
             <a:avLst/>
@@ -12156,7 +12156,7 @@
                 <a:ea typeface="Inter" pitchFamily="34" charset="-122"/>
                 <a:cs typeface="Inter" pitchFamily="34" charset="-120"/>
               </a:rPr>
-              <a:t>Find the block at the very top of the file. Swap in your eight to ten questions.</a:t>
+              <a:t>It is on the opening screen. Fill in the form: type them, paste a list, or let the AI prompt draft a round.</a:t>
             </a:r>
             <a:endParaRPr lang="en-US" sz="1600" dirty="0"/>
           </a:p>
@@ -12170,12 +12170,12 @@
         </p:nvSpPr>
         <p:spPr>
           <a:xfrm>
-            <a:off x="640080" y="4343400"/>
-            <a:ext cx="10972800" cy="1234440"/>
+            <a:off x="640080" y="3575304"/>
+            <a:ext cx="10972800" cy="969264"/>
           </a:xfrm>
           <a:prstGeom prst="roundRect">
             <a:avLst>
-              <a:gd name="adj" fmla="val 6667"/>
+              <a:gd name="adj" fmla="val 8491"/>
             </a:avLst>
           </a:prstGeom>
           <a:solidFill>
@@ -12197,8 +12197,8 @@
         </p:nvSpPr>
         <p:spPr>
           <a:xfrm>
-            <a:off x="914400" y="4727448"/>
-            <a:ext cx="502920" cy="502920"/>
+            <a:off x="914400" y="3822192"/>
+            <a:ext cx="475488" cy="475488"/>
           </a:xfrm>
           <a:prstGeom prst="ellipse">
             <a:avLst/>
@@ -12222,8 +12222,8 @@
         </p:nvSpPr>
         <p:spPr>
           <a:xfrm>
-            <a:off x="914400" y="4727448"/>
-            <a:ext cx="502920" cy="502920"/>
+            <a:off x="914400" y="3822192"/>
+            <a:ext cx="475488" cy="475488"/>
           </a:xfrm>
           <a:prstGeom prst="rect">
             <a:avLst/>
@@ -12261,8 +12261,8 @@
         </p:nvSpPr>
         <p:spPr>
           <a:xfrm>
-            <a:off x="1645920" y="4489704"/>
-            <a:ext cx="9692640" cy="457200"/>
+            <a:off x="1645920" y="3666744"/>
+            <a:ext cx="9692640" cy="384048"/>
           </a:xfrm>
           <a:prstGeom prst="rect">
             <a:avLst/>
@@ -12300,8 +12300,8 @@
         </p:nvSpPr>
         <p:spPr>
           <a:xfrm>
-            <a:off x="1645920" y="4965192"/>
-            <a:ext cx="9692640" cy="548640"/>
+            <a:off x="1645920" y="4069080"/>
+            <a:ext cx="9692640" cy="411480"/>
           </a:xfrm>
           <a:prstGeom prst="rect">
             <a:avLst/>
@@ -12326,6 +12326,175 @@
                 <a:cs typeface="Inter" pitchFamily="34" charset="-120"/>
               </a:rPr>
               <a:t>One cosmetic (how it looks). One behavioral (how it plays). Test after each one.</a:t>
+            </a:r>
+            <a:endParaRPr lang="en-US" sz="1600" dirty="0"/>
+          </a:p>
+        </p:txBody>
+      </p:sp>
+      <p:sp>
+        <p:nvSpPr>
+          <p:cNvPr id="29" name="Shape 26"/>
+          <p:cNvSpPr/>
+          <p:nvPr/>
+        </p:nvSpPr>
+        <p:spPr>
+          <a:xfrm>
+            <a:off x="640080" y="4654296"/>
+            <a:ext cx="10972800" cy="969264"/>
+          </a:xfrm>
+          <a:prstGeom prst="roundRect">
+            <a:avLst>
+              <a:gd name="adj" fmla="val 8491"/>
+            </a:avLst>
+          </a:prstGeom>
+          <a:solidFill>
+            <a:srgbClr val="F7F5F0"/>
+          </a:solidFill>
+          <a:ln w="12700">
+            <a:solidFill>
+              <a:srgbClr val="F7F5F0"/>
+            </a:solidFill>
+            <a:prstDash val="solid"/>
+          </a:ln>
+        </p:spPr>
+      </p:sp>
+      <p:sp>
+        <p:nvSpPr>
+          <p:cNvPr id="30" name="Shape 27"/>
+          <p:cNvSpPr/>
+          <p:nvPr/>
+        </p:nvSpPr>
+        <p:spPr>
+          <a:xfrm>
+            <a:off x="914400" y="4901184"/>
+            <a:ext cx="475488" cy="475488"/>
+          </a:xfrm>
+          <a:prstGeom prst="ellipse">
+            <a:avLst/>
+          </a:prstGeom>
+          <a:solidFill>
+            <a:srgbClr val="2A9D8F"/>
+          </a:solidFill>
+          <a:ln w="12700">
+            <a:solidFill>
+              <a:srgbClr val="2A9D8F"/>
+            </a:solidFill>
+            <a:prstDash val="solid"/>
+          </a:ln>
+        </p:spPr>
+      </p:sp>
+      <p:sp>
+        <p:nvSpPr>
+          <p:cNvPr id="31" name="Text 28"/>
+          <p:cNvSpPr/>
+          <p:nvPr/>
+        </p:nvSpPr>
+        <p:spPr>
+          <a:xfrm>
+            <a:off x="914400" y="4901184"/>
+            <a:ext cx="475488" cy="475488"/>
+          </a:xfrm>
+          <a:prstGeom prst="rect">
+            <a:avLst/>
+          </a:prstGeom>
+          <a:noFill/>
+          <a:ln/>
+        </p:spPr>
+        <p:txBody>
+          <a:bodyPr wrap="square" lIns="0" tIns="0" rIns="0" bIns="0" rtlCol="0" anchor="ctr"/>
+          <a:lstStyle/>
+          <a:p>
+            <a:pPr algn="ctr" indent="0" marL="0">
+              <a:buNone/>
+            </a:pPr>
+            <a:r>
+              <a:rPr lang="en-US" sz="2000" b="1" dirty="0">
+                <a:solidFill>
+                  <a:srgbClr val="FFFFFF"/>
+                </a:solidFill>
+                <a:latin typeface="Inter" pitchFamily="34" charset="0"/>
+                <a:ea typeface="Inter" pitchFamily="34" charset="-122"/>
+                <a:cs typeface="Inter" pitchFamily="34" charset="-120"/>
+              </a:rPr>
+              <a:t>4</a:t>
+            </a:r>
+            <a:endParaRPr lang="en-US" sz="2000" dirty="0"/>
+          </a:p>
+        </p:txBody>
+      </p:sp>
+      <p:sp>
+        <p:nvSpPr>
+          <p:cNvPr id="32" name="Text 29"/>
+          <p:cNvSpPr/>
+          <p:nvPr/>
+        </p:nvSpPr>
+        <p:spPr>
+          <a:xfrm>
+            <a:off x="1645920" y="4745736"/>
+            <a:ext cx="9692640" cy="384048"/>
+          </a:xfrm>
+          <a:prstGeom prst="rect">
+            <a:avLst/>
+          </a:prstGeom>
+          <a:noFill/>
+          <a:ln/>
+        </p:spPr>
+        <p:txBody>
+          <a:bodyPr wrap="square" lIns="0" tIns="0" rIns="0" bIns="0" rtlCol="0" anchor="ctr"/>
+          <a:lstStyle/>
+          <a:p>
+            <a:pPr indent="0" marL="0">
+              <a:buNone/>
+            </a:pPr>
+            <a:r>
+              <a:rPr lang="en-US" sz="1900" b="1" dirty="0">
+                <a:solidFill>
+                  <a:srgbClr val="13293D"/>
+                </a:solidFill>
+                <a:latin typeface="Inter" pitchFamily="34" charset="0"/>
+                <a:ea typeface="Inter" pitchFamily="34" charset="-122"/>
+                <a:cs typeface="Inter" pitchFamily="34" charset="-120"/>
+              </a:rPr>
+              <a:t>Press “Save my game as a file”</a:t>
+            </a:r>
+            <a:endParaRPr lang="en-US" sz="1900" dirty="0"/>
+          </a:p>
+        </p:txBody>
+      </p:sp>
+      <p:sp>
+        <p:nvSpPr>
+          <p:cNvPr id="33" name="Text 30"/>
+          <p:cNvSpPr/>
+          <p:nvPr/>
+        </p:nvSpPr>
+        <p:spPr>
+          <a:xfrm>
+            <a:off x="1645920" y="5148072"/>
+            <a:ext cx="9692640" cy="411480"/>
+          </a:xfrm>
+          <a:prstGeom prst="rect">
+            <a:avLst/>
+          </a:prstGeom>
+          <a:noFill/>
+          <a:ln/>
+        </p:spPr>
+        <p:txBody>
+          <a:bodyPr wrap="square" lIns="0" tIns="0" rIns="0" bIns="0" rtlCol="0" anchor="ctr"/>
+          <a:lstStyle/>
+          <a:p>
+            <a:pPr indent="0" marL="0">
+              <a:buNone/>
+            </a:pPr>
+            <a:r>
+              <a:rPr lang="en-US" sz="1600" dirty="0">
+                <a:solidFill>
+                  <a:srgbClr val="1B1F24"/>
+                </a:solidFill>
+                <a:latin typeface="Inter" pitchFamily="34" charset="0"/>
+                <a:ea typeface="Inter" pitchFamily="34" charset="-122"/>
+                <a:cs typeface="Inter" pitchFamily="34" charset="-120"/>
+              </a:rPr>
+              <a:t>That file is yours to keep, copy and hand out. You walk out with it.</a:t>
             </a:r>
             <a:endParaRPr lang="en-US" sz="1600" dirty="0"/>
           </a:p>
@@ -12680,7 +12849,7 @@
                 <a:ea typeface="Inter" pitchFamily="34" charset="-122"/>
                 <a:cs typeface="Inter" pitchFamily="34" charset="-120"/>
               </a:rPr>
-              <a:t>Her question block: eight to ten entries, the same shape every time.</a:t>
+              <a:t>Her setup screen: type, paste a list, or let AI draft a round.</a:t>
             </a:r>
             <a:endParaRPr lang="en-US" sz="1000" dirty="0"/>
           </a:p>
@@ -12719,7 +12888,7 @@
                 <a:ea typeface="Inter" pitchFamily="34" charset="-122"/>
                 <a:cs typeface="Inter" pitchFamily="34" charset="-120"/>
               </a:rPr>
-              <a:t>LAB SUPPORT · WHERE YOUR CONTENT LIVES</a:t>
+              <a:t>LAB SUPPORT · WHERE YOUR CONTENT GOES</a:t>
             </a:r>
             <a:endParaRPr lang="en-US" sz="1200" dirty="0"/>
           </a:p>
@@ -12758,7 +12927,7 @@
                 <a:ea typeface="Inter" pitchFamily="34" charset="-122"/>
                 <a:cs typeface="Inter" pitchFamily="34" charset="-120"/>
               </a:rPr>
-              <a:t>The question block, up close</a:t>
+              <a:t>The setup screen, up close</a:t>
             </a:r>
             <a:endParaRPr lang="en-US" sz="3200" dirty="0"/>
           </a:p>
@@ -12773,11 +12942,335 @@
         <p:spPr>
           <a:xfrm>
             <a:off x="640080" y="1554480"/>
-            <a:ext cx="10972800" cy="3200400"/>
+            <a:ext cx="3547872" cy="2788920"/>
           </a:xfrm>
           <a:prstGeom prst="roundRect">
             <a:avLst>
-              <a:gd name="adj" fmla="val 2571"/>
+              <a:gd name="adj" fmla="val 2951"/>
+            </a:avLst>
+          </a:prstGeom>
+          <a:solidFill>
+            <a:srgbClr val="EAF5F3"/>
+          </a:solidFill>
+          <a:ln w="12700">
+            <a:solidFill>
+              <a:srgbClr val="EAF5F3"/>
+            </a:solidFill>
+            <a:prstDash val="solid"/>
+          </a:ln>
+        </p:spPr>
+      </p:sp>
+      <p:sp>
+        <p:nvSpPr>
+          <p:cNvPr id="15" name="Text 12"/>
+          <p:cNvSpPr/>
+          <p:nvPr/>
+        </p:nvSpPr>
+        <p:spPr>
+          <a:xfrm>
+            <a:off x="868680" y="1691640"/>
+            <a:ext cx="3108960" cy="457200"/>
+          </a:xfrm>
+          <a:prstGeom prst="rect">
+            <a:avLst/>
+          </a:prstGeom>
+          <a:noFill/>
+          <a:ln/>
+        </p:spPr>
+        <p:txBody>
+          <a:bodyPr wrap="square" lIns="0" tIns="0" rIns="0" bIns="0" rtlCol="0" anchor="ctr"/>
+          <a:lstStyle/>
+          <a:p>
+            <a:pPr indent="0" marL="0">
+              <a:buNone/>
+            </a:pPr>
+            <a:r>
+              <a:rPr lang="en-US" sz="1900" b="1" dirty="0">
+                <a:solidFill>
+                  <a:srgbClr val="13293D"/>
+                </a:solidFill>
+                <a:latin typeface="Inter" pitchFamily="34" charset="0"/>
+                <a:ea typeface="Inter" pitchFamily="34" charset="-122"/>
+                <a:cs typeface="Inter" pitchFamily="34" charset="-120"/>
+              </a:rPr>
+              <a:t>1 · Type them</a:t>
+            </a:r>
+            <a:endParaRPr lang="en-US" sz="1900" dirty="0"/>
+          </a:p>
+        </p:txBody>
+      </p:sp>
+      <p:sp>
+        <p:nvSpPr>
+          <p:cNvPr id="16" name="Text 13"/>
+          <p:cNvSpPr/>
+          <p:nvPr/>
+        </p:nvSpPr>
+        <p:spPr>
+          <a:xfrm>
+            <a:off x="868680" y="2240280"/>
+            <a:ext cx="3108960" cy="1965960"/>
+          </a:xfrm>
+          <a:prstGeom prst="rect">
+            <a:avLst/>
+          </a:prstGeom>
+          <a:noFill/>
+          <a:ln/>
+        </p:spPr>
+        <p:txBody>
+          <a:bodyPr wrap="square" lIns="0" tIns="0" rIns="0" bIns="0" rtlCol="0" anchor="t"/>
+          <a:lstStyle/>
+          <a:p>
+            <a:pPr indent="0" marL="0">
+              <a:lnSpc>
+                <a:spcPct val="120000"/>
+              </a:lnSpc>
+              <a:buNone/>
+            </a:pPr>
+            <a:r>
+              <a:rPr lang="en-US" sz="1600" dirty="0">
+                <a:solidFill>
+                  <a:srgbClr val="1B1F24"/>
+                </a:solidFill>
+                <a:latin typeface="Inter" pitchFamily="34" charset="0"/>
+                <a:ea typeface="Inter" pitchFamily="34" charset="-122"/>
+                <a:cs typeface="Inter" pitchFamily="34" charset="-120"/>
+              </a:rPr>
+              <a:t>One card per question: the question, four answers, the idea it tests, a level, and one line saying why it is right.</a:t>
+            </a:r>
+            <a:endParaRPr lang="en-US" sz="1600" dirty="0"/>
+          </a:p>
+        </p:txBody>
+      </p:sp>
+      <p:sp>
+        <p:nvSpPr>
+          <p:cNvPr id="17" name="Shape 14"/>
+          <p:cNvSpPr/>
+          <p:nvPr/>
+        </p:nvSpPr>
+        <p:spPr>
+          <a:xfrm>
+            <a:off x="4352544" y="1554480"/>
+            <a:ext cx="3547872" cy="2788920"/>
+          </a:xfrm>
+          <a:prstGeom prst="roundRect">
+            <a:avLst>
+              <a:gd name="adj" fmla="val 2951"/>
+            </a:avLst>
+          </a:prstGeom>
+          <a:solidFill>
+            <a:srgbClr val="F7F5F0"/>
+          </a:solidFill>
+          <a:ln w="12700">
+            <a:solidFill>
+              <a:srgbClr val="F7F5F0"/>
+            </a:solidFill>
+            <a:prstDash val="solid"/>
+          </a:ln>
+        </p:spPr>
+      </p:sp>
+      <p:sp>
+        <p:nvSpPr>
+          <p:cNvPr id="18" name="Text 15"/>
+          <p:cNvSpPr/>
+          <p:nvPr/>
+        </p:nvSpPr>
+        <p:spPr>
+          <a:xfrm>
+            <a:off x="4581144" y="1691640"/>
+            <a:ext cx="3108960" cy="457200"/>
+          </a:xfrm>
+          <a:prstGeom prst="rect">
+            <a:avLst/>
+          </a:prstGeom>
+          <a:noFill/>
+          <a:ln/>
+        </p:spPr>
+        <p:txBody>
+          <a:bodyPr wrap="square" lIns="0" tIns="0" rIns="0" bIns="0" rtlCol="0" anchor="ctr"/>
+          <a:lstStyle/>
+          <a:p>
+            <a:pPr indent="0" marL="0">
+              <a:buNone/>
+            </a:pPr>
+            <a:r>
+              <a:rPr lang="en-US" sz="1900" b="1" dirty="0">
+                <a:solidFill>
+                  <a:srgbClr val="13293D"/>
+                </a:solidFill>
+                <a:latin typeface="Inter" pitchFamily="34" charset="0"/>
+                <a:ea typeface="Inter" pitchFamily="34" charset="-122"/>
+                <a:cs typeface="Inter" pitchFamily="34" charset="-120"/>
+              </a:rPr>
+              <a:t>2 · Paste a list</a:t>
+            </a:r>
+            <a:endParaRPr lang="en-US" sz="1900" dirty="0"/>
+          </a:p>
+        </p:txBody>
+      </p:sp>
+      <p:sp>
+        <p:nvSpPr>
+          <p:cNvPr id="19" name="Text 16"/>
+          <p:cNvSpPr/>
+          <p:nvPr/>
+        </p:nvSpPr>
+        <p:spPr>
+          <a:xfrm>
+            <a:off x="4581144" y="2240280"/>
+            <a:ext cx="3108960" cy="1965960"/>
+          </a:xfrm>
+          <a:prstGeom prst="rect">
+            <a:avLst/>
+          </a:prstGeom>
+          <a:noFill/>
+          <a:ln/>
+        </p:spPr>
+        <p:txBody>
+          <a:bodyPr wrap="square" lIns="0" tIns="0" rIns="0" bIns="0" rtlCol="0" anchor="t"/>
+          <a:lstStyle/>
+          <a:p>
+            <a:pPr indent="0" marL="0">
+              <a:lnSpc>
+                <a:spcPct val="120000"/>
+              </a:lnSpc>
+              <a:buNone/>
+            </a:pPr>
+            <a:r>
+              <a:rPr lang="en-US" sz="1600" dirty="0">
+                <a:solidFill>
+                  <a:srgbClr val="1B1F24"/>
+                </a:solidFill>
+                <a:latin typeface="Inter" pitchFamily="34" charset="0"/>
+                <a:ea typeface="Inter" pitchFamily="34" charset="-122"/>
+                <a:cs typeface="Inter" pitchFamily="34" charset="-120"/>
+              </a:rPr>
+              <a:t>One question per line, eight parts split by the | character. The page loads it and names every line it skipped, and why.</a:t>
+            </a:r>
+            <a:endParaRPr lang="en-US" sz="1600" dirty="0"/>
+          </a:p>
+        </p:txBody>
+      </p:sp>
+      <p:sp>
+        <p:nvSpPr>
+          <p:cNvPr id="20" name="Shape 17"/>
+          <p:cNvSpPr/>
+          <p:nvPr/>
+        </p:nvSpPr>
+        <p:spPr>
+          <a:xfrm>
+            <a:off x="8065008" y="1554480"/>
+            <a:ext cx="3547872" cy="2788920"/>
+          </a:xfrm>
+          <a:prstGeom prst="roundRect">
+            <a:avLst>
+              <a:gd name="adj" fmla="val 2951"/>
+            </a:avLst>
+          </a:prstGeom>
+          <a:solidFill>
+            <a:srgbClr val="FBF3DC"/>
+          </a:solidFill>
+          <a:ln w="12700">
+            <a:solidFill>
+              <a:srgbClr val="FBF3DC"/>
+            </a:solidFill>
+            <a:prstDash val="solid"/>
+          </a:ln>
+        </p:spPr>
+      </p:sp>
+      <p:sp>
+        <p:nvSpPr>
+          <p:cNvPr id="21" name="Text 18"/>
+          <p:cNvSpPr/>
+          <p:nvPr/>
+        </p:nvSpPr>
+        <p:spPr>
+          <a:xfrm>
+            <a:off x="8293608" y="1691640"/>
+            <a:ext cx="3108960" cy="457200"/>
+          </a:xfrm>
+          <a:prstGeom prst="rect">
+            <a:avLst/>
+          </a:prstGeom>
+          <a:noFill/>
+          <a:ln/>
+        </p:spPr>
+        <p:txBody>
+          <a:bodyPr wrap="square" lIns="0" tIns="0" rIns="0" bIns="0" rtlCol="0" anchor="ctr"/>
+          <a:lstStyle/>
+          <a:p>
+            <a:pPr indent="0" marL="0">
+              <a:buNone/>
+            </a:pPr>
+            <a:r>
+              <a:rPr lang="en-US" sz="1900" b="1" dirty="0">
+                <a:solidFill>
+                  <a:srgbClr val="13293D"/>
+                </a:solidFill>
+                <a:latin typeface="Inter" pitchFamily="34" charset="0"/>
+                <a:ea typeface="Inter" pitchFamily="34" charset="-122"/>
+                <a:cs typeface="Inter" pitchFamily="34" charset="-120"/>
+              </a:rPr>
+              <a:t>3 · Let AI draft a round</a:t>
+            </a:r>
+            <a:endParaRPr lang="en-US" sz="1900" dirty="0"/>
+          </a:p>
+        </p:txBody>
+      </p:sp>
+      <p:sp>
+        <p:nvSpPr>
+          <p:cNvPr id="22" name="Text 19"/>
+          <p:cNvSpPr/>
+          <p:nvPr/>
+        </p:nvSpPr>
+        <p:spPr>
+          <a:xfrm>
+            <a:off x="8293608" y="2240280"/>
+            <a:ext cx="3108960" cy="1965960"/>
+          </a:xfrm>
+          <a:prstGeom prst="rect">
+            <a:avLst/>
+          </a:prstGeom>
+          <a:noFill/>
+          <a:ln/>
+        </p:spPr>
+        <p:txBody>
+          <a:bodyPr wrap="square" lIns="0" tIns="0" rIns="0" bIns="0" rtlCol="0" anchor="t"/>
+          <a:lstStyle/>
+          <a:p>
+            <a:pPr indent="0" marL="0">
+              <a:lnSpc>
+                <a:spcPct val="120000"/>
+              </a:lnSpc>
+              <a:buNone/>
+            </a:pPr>
+            <a:r>
+              <a:rPr lang="en-US" sz="1600" dirty="0">
+                <a:solidFill>
+                  <a:srgbClr val="1B1F24"/>
+                </a:solidFill>
+                <a:latin typeface="Inter" pitchFamily="34" charset="0"/>
+                <a:ea typeface="Inter" pitchFamily="34" charset="-122"/>
+                <a:cs typeface="Inter" pitchFamily="34" charset="-120"/>
+              </a:rPr>
+              <a:t>Type your topic, press Copy the prompt, paste it into any AI tool, paste the answer back. Fast, and it still needs your eyes.</a:t>
+            </a:r>
+            <a:endParaRPr lang="en-US" sz="1600" dirty="0"/>
+          </a:p>
+        </p:txBody>
+      </p:sp>
+      <p:sp>
+        <p:nvSpPr>
+          <p:cNvPr id="23" name="Shape 20"/>
+          <p:cNvSpPr/>
+          <p:nvPr/>
+        </p:nvSpPr>
+        <p:spPr>
+          <a:xfrm>
+            <a:off x="640080" y="4526280"/>
+            <a:ext cx="10972800" cy="1005840"/>
+          </a:xfrm>
+          <a:prstGeom prst="roundRect">
+            <a:avLst>
+              <a:gd name="adj" fmla="val 8182"/>
             </a:avLst>
           </a:prstGeom>
           <a:solidFill>
@@ -12793,282 +13286,67 @@
       </p:sp>
       <p:sp>
         <p:nvSpPr>
-          <p:cNvPr id="15" name="Text 12"/>
-          <p:cNvSpPr/>
-          <p:nvPr/>
-        </p:nvSpPr>
-        <p:spPr>
-          <a:xfrm>
-            <a:off x="960120" y="1783080"/>
-            <a:ext cx="10332720" cy="2743200"/>
-          </a:xfrm>
-          <a:prstGeom prst="rect">
-            <a:avLst/>
-          </a:prstGeom>
-          <a:noFill/>
-          <a:ln/>
-        </p:spPr>
-        <p:txBody>
-          <a:bodyPr wrap="square" lIns="0" tIns="0" rIns="0" bIns="0" rtlCol="0" anchor="t"/>
-          <a:lstStyle/>
-          <a:p>
-            <a:pPr indent="0" marL="0">
-              <a:lnSpc>
-                <a:spcPct val="130000"/>
-              </a:lnSpc>
-              <a:buNone/>
-            </a:pPr>
-            <a:r>
-              <a:rPr lang="en-US" sz="1500" dirty="0">
-                <a:solidFill>
-                  <a:srgbClr val="9FB2C2"/>
-                </a:solidFill>
-                <a:latin typeface="Courier New" pitchFamily="34" charset="0"/>
-                <a:ea typeface="Courier New" pitchFamily="34" charset="-122"/>
-                <a:cs typeface="Courier New" pitchFamily="34" charset="-120"/>
-              </a:rPr>
-              <a:t>const QUESTIONS = [
-</a:t>
-            </a:r>
-            <a:pPr indent="0" marL="0">
-              <a:lnSpc>
-                <a:spcPct val="130000"/>
-              </a:lnSpc>
-              <a:buNone/>
-            </a:pPr>
-            <a:r>
-              <a:rPr lang="en-US" sz="1500" dirty="0">
-                <a:solidFill>
-                  <a:srgbClr val="C9D4DE"/>
-                </a:solidFill>
-                <a:latin typeface="Courier New" pitchFamily="34" charset="0"/>
-                <a:ea typeface="Courier New" pitchFamily="34" charset="-122"/>
-                <a:cs typeface="Courier New" pitchFamily="34" charset="-120"/>
-              </a:rPr>
-              <a:t>  { q: </a:t>
-            </a:r>
-            <a:pPr indent="0" marL="0">
-              <a:lnSpc>
-                <a:spcPct val="130000"/>
-              </a:lnSpc>
-              <a:buNone/>
-            </a:pPr>
-            <a:r>
-              <a:rPr lang="en-US" sz="1500" dirty="0">
+          <p:cNvPr id="24" name="Text 21"/>
+          <p:cNvSpPr/>
+          <p:nvPr/>
+        </p:nvSpPr>
+        <p:spPr>
+          <a:xfrm>
+            <a:off x="914400" y="4526280"/>
+            <a:ext cx="10424160" cy="1005840"/>
+          </a:xfrm>
+          <a:prstGeom prst="rect">
+            <a:avLst/>
+          </a:prstGeom>
+          <a:noFill/>
+          <a:ln/>
+        </p:spPr>
+        <p:txBody>
+          <a:bodyPr wrap="square" lIns="0" tIns="0" rIns="0" bIns="0" rtlCol="0" anchor="ctr"/>
+          <a:lstStyle/>
+          <a:p>
+            <a:pPr indent="0" marL="0">
+              <a:buNone/>
+            </a:pPr>
+            <a:r>
+              <a:rPr lang="en-US" sz="1800" b="1" dirty="0">
                 <a:solidFill>
                   <a:srgbClr val="F4A825"/>
                 </a:solidFill>
-                <a:latin typeface="Courier New" pitchFamily="34" charset="0"/>
-                <a:ea typeface="Courier New" pitchFamily="34" charset="-122"/>
-                <a:cs typeface="Courier New" pitchFamily="34" charset="-120"/>
-              </a:rPr>
-              <a:t>your question here</a:t>
-            </a:r>
-            <a:pPr indent="0" marL="0">
-              <a:lnSpc>
-                <a:spcPct val="130000"/>
-              </a:lnSpc>
-              <a:buNone/>
-            </a:pPr>
-            <a:r>
-              <a:rPr lang="en-US" sz="1500" dirty="0">
-                <a:solidFill>
-                  <a:srgbClr val="C9D4DE"/>
-                </a:solidFill>
-                <a:latin typeface="Courier New" pitchFamily="34" charset="0"/>
-                <a:ea typeface="Courier New" pitchFamily="34" charset="-122"/>
-                <a:cs typeface="Courier New" pitchFamily="34" charset="-120"/>
-              </a:rPr>
-              <a:t>,
-</a:t>
-            </a:r>
-            <a:pPr indent="0" marL="0">
-              <a:lnSpc>
-                <a:spcPct val="130000"/>
-              </a:lnSpc>
-              <a:buNone/>
-            </a:pPr>
-            <a:r>
-              <a:rPr lang="en-US" sz="1500" dirty="0">
-                <a:solidFill>
-                  <a:srgbClr val="C9D4DE"/>
-                </a:solidFill>
-                <a:latin typeface="Courier New" pitchFamily="34" charset="0"/>
-                <a:ea typeface="Courier New" pitchFamily="34" charset="-122"/>
-                <a:cs typeface="Courier New" pitchFamily="34" charset="-120"/>
-              </a:rPr>
-              <a:t>    a: [</a:t>
-            </a:r>
-            <a:pPr indent="0" marL="0">
-              <a:lnSpc>
-                <a:spcPct val="130000"/>
-              </a:lnSpc>
-              <a:buNone/>
-            </a:pPr>
-            <a:r>
-              <a:rPr lang="en-US" sz="1500" dirty="0">
-                <a:solidFill>
-                  <a:srgbClr val="F4A825"/>
-                </a:solidFill>
-                <a:latin typeface="Courier New" pitchFamily="34" charset="0"/>
-                <a:ea typeface="Courier New" pitchFamily="34" charset="-122"/>
-                <a:cs typeface="Courier New" pitchFamily="34" charset="-120"/>
-              </a:rPr>
-              <a:t>four answer choices</a:t>
-            </a:r>
-            <a:pPr indent="0" marL="0">
-              <a:lnSpc>
-                <a:spcPct val="130000"/>
-              </a:lnSpc>
-              <a:buNone/>
-            </a:pPr>
-            <a:r>
-              <a:rPr lang="en-US" sz="1500" dirty="0">
-                <a:solidFill>
-                  <a:srgbClr val="C9D4DE"/>
-                </a:solidFill>
-                <a:latin typeface="Courier New" pitchFamily="34" charset="0"/>
-                <a:ea typeface="Courier New" pitchFamily="34" charset="-122"/>
-                <a:cs typeface="Courier New" pitchFamily="34" charset="-120"/>
-              </a:rPr>
-              <a:t>], ok: 0,
-</a:t>
-            </a:r>
-            <a:pPr indent="0" marL="0">
-              <a:lnSpc>
-                <a:spcPct val="130000"/>
-              </a:lnSpc>
-              <a:buNone/>
-            </a:pPr>
-            <a:r>
-              <a:rPr lang="en-US" sz="1500" dirty="0">
-                <a:solidFill>
-                  <a:srgbClr val="C9D4DE"/>
-                </a:solidFill>
-                <a:latin typeface="Courier New" pitchFamily="34" charset="0"/>
-                <a:ea typeface="Courier New" pitchFamily="34" charset="-122"/>
-                <a:cs typeface="Courier New" pitchFamily="34" charset="-120"/>
-              </a:rPr>
-              <a:t>    idea: </a:t>
-            </a:r>
-            <a:pPr indent="0" marL="0">
-              <a:lnSpc>
-                <a:spcPct val="130000"/>
-              </a:lnSpc>
-              <a:buNone/>
-            </a:pPr>
-            <a:r>
-              <a:rPr lang="en-US" sz="1500" dirty="0">
-                <a:solidFill>
-                  <a:srgbClr val="F4A825"/>
-                </a:solidFill>
-                <a:latin typeface="Courier New" pitchFamily="34" charset="0"/>
-                <a:ea typeface="Courier New" pitchFamily="34" charset="-122"/>
-                <a:cs typeface="Courier New" pitchFamily="34" charset="-120"/>
-              </a:rPr>
-              <a:t>the concept it tests</a:t>
-            </a:r>
-            <a:pPr indent="0" marL="0">
-              <a:lnSpc>
-                <a:spcPct val="130000"/>
-              </a:lnSpc>
-              <a:buNone/>
-            </a:pPr>
-            <a:r>
-              <a:rPr lang="en-US" sz="1500" dirty="0">
-                <a:solidFill>
-                  <a:srgbClr val="C9D4DE"/>
-                </a:solidFill>
-                <a:latin typeface="Courier New" pitchFamily="34" charset="0"/>
-                <a:ea typeface="Courier New" pitchFamily="34" charset="-122"/>
-                <a:cs typeface="Courier New" pitchFamily="34" charset="-120"/>
-              </a:rPr>
-              <a:t>, level: 1,
-</a:t>
-            </a:r>
-            <a:pPr indent="0" marL="0">
-              <a:lnSpc>
-                <a:spcPct val="130000"/>
-              </a:lnSpc>
-              <a:buNone/>
-            </a:pPr>
-            <a:r>
-              <a:rPr lang="en-US" sz="1500" dirty="0">
-                <a:solidFill>
-                  <a:srgbClr val="C9D4DE"/>
-                </a:solidFill>
-                <a:latin typeface="Courier New" pitchFamily="34" charset="0"/>
-                <a:ea typeface="Courier New" pitchFamily="34" charset="-122"/>
-                <a:cs typeface="Courier New" pitchFamily="34" charset="-120"/>
-              </a:rPr>
-              <a:t>    why: </a:t>
-            </a:r>
-            <a:pPr indent="0" marL="0">
-              <a:lnSpc>
-                <a:spcPct val="130000"/>
-              </a:lnSpc>
-              <a:buNone/>
-            </a:pPr>
-            <a:r>
-              <a:rPr lang="en-US" sz="1500" dirty="0">
-                <a:solidFill>
-                  <a:srgbClr val="F4A825"/>
-                </a:solidFill>
-                <a:latin typeface="Courier New" pitchFamily="34" charset="0"/>
-                <a:ea typeface="Courier New" pitchFamily="34" charset="-122"/>
-                <a:cs typeface="Courier New" pitchFamily="34" charset="-120"/>
-              </a:rPr>
-              <a:t>one line saying why it is right</a:t>
-            </a:r>
-            <a:pPr indent="0" marL="0">
-              <a:lnSpc>
-                <a:spcPct val="130000"/>
-              </a:lnSpc>
-              <a:buNone/>
-            </a:pPr>
-            <a:r>
-              <a:rPr lang="en-US" sz="1500" dirty="0">
-                <a:solidFill>
-                  <a:srgbClr val="C9D4DE"/>
-                </a:solidFill>
-                <a:latin typeface="Courier New" pitchFamily="34" charset="0"/>
-                <a:ea typeface="Courier New" pitchFamily="34" charset="-122"/>
-                <a:cs typeface="Courier New" pitchFamily="34" charset="-120"/>
-              </a:rPr>
-              <a:t> },
-</a:t>
-            </a:r>
-            <a:pPr indent="0" marL="0">
-              <a:lnSpc>
-                <a:spcPct val="130000"/>
-              </a:lnSpc>
-              <a:buNone/>
-            </a:pPr>
-            <a:r>
-              <a:rPr lang="en-US" sz="1500" i="1" dirty="0">
-                <a:solidFill>
-                  <a:srgbClr val="9FB2C2"/>
-                </a:solidFill>
-                <a:latin typeface="Courier New" pitchFamily="34" charset="0"/>
-                <a:ea typeface="Courier New" pitchFamily="34" charset="-122"/>
-                <a:cs typeface="Courier New" pitchFamily="34" charset="-120"/>
-              </a:rPr>
-              <a:t>  … eight to ten of these</a:t>
-            </a:r>
-            <a:endParaRPr lang="en-US" sz="1500" dirty="0"/>
-          </a:p>
-        </p:txBody>
-      </p:sp>
-      <p:sp>
-        <p:nvSpPr>
-          <p:cNvPr id="16" name="Text 13"/>
-          <p:cNvSpPr/>
-          <p:nvPr/>
-        </p:nvSpPr>
-        <p:spPr>
-          <a:xfrm>
-            <a:off x="640080" y="4937760"/>
-            <a:ext cx="10972800" cy="548640"/>
+                <a:latin typeface="Inter" pitchFamily="34" charset="0"/>
+                <a:ea typeface="Inter" pitchFamily="34" charset="-122"/>
+                <a:cs typeface="Inter" pitchFamily="34" charset="-120"/>
+              </a:rPr>
+              <a:t>Fast is not the same as right. </a:t>
+            </a:r>
+            <a:pPr indent="0" marL="0">
+              <a:buNone/>
+            </a:pPr>
+            <a:r>
+              <a:rPr lang="en-US" sz="1800" dirty="0">
+                <a:solidFill>
+                  <a:srgbClr val="FFFFFF"/>
+                </a:solidFill>
+                <a:latin typeface="Inter" pitchFamily="34" charset="0"/>
+                <a:ea typeface="Inter" pitchFamily="34" charset="-122"/>
+                <a:cs typeface="Inter" pitchFamily="34" charset="-120"/>
+              </a:rPr>
+              <a:t>Read every drafted question before anyone plays it, and fix the ones that are off in the form. AI drafts, the teacher decides.</a:t>
+            </a:r>
+            <a:endParaRPr lang="en-US" sz="1800" dirty="0"/>
+          </a:p>
+        </p:txBody>
+      </p:sp>
+      <p:sp>
+        <p:nvSpPr>
+          <p:cNvPr id="25" name="Text 22"/>
+          <p:cNvSpPr/>
+          <p:nvPr/>
+        </p:nvSpPr>
+        <p:spPr>
+          <a:xfrm>
+            <a:off x="640080" y="5669280"/>
+            <a:ext cx="10972800" cy="457200"/>
           </a:xfrm>
           <a:prstGeom prst="rect">
             <a:avLst/>
@@ -13092,7 +13370,7 @@
                 <a:ea typeface="Inter" pitchFamily="34" charset="-122"/>
                 <a:cs typeface="Inter" pitchFamily="34" charset="-120"/>
               </a:rPr>
-              <a:t>Same shape, every entry. Type your own questions directly, or describe them to the AI and let it fill the shape in for you.</a:t>
+              <a:t>The “idea” is two or three words naming the concept. The game brings a missed idea back later, so use three or four ideas per round.</a:t>
             </a:r>
             <a:endParaRPr lang="en-US" sz="1600" dirty="0"/>
           </a:p>
@@ -15531,7 +15809,7 @@
                 <a:ea typeface="Inter" pitchFamily="34" charset="-122"/>
                 <a:cs typeface="Inter" pitchFamily="34" charset="-120"/>
               </a:rPr>
-              <a:t>Under thirty seconds, every time this has happened in testing.</a:t>
+              <a:t>Usually a quick fix. Stay calm and say it out loud.</a:t>
             </a:r>
             <a:endParaRPr lang="en-US" sz="1500" dirty="0"/>
           </a:p>

</xml_diff>